<commit_message>
Update test count in deck from 28 to 29 (new --with-confidence test)
The pytest suite grew to 29 tests with the --with-confidence CLI test
added in the previous commit; the deck still said 28 in three places
(slides 7 and 9). PDF export regenerated to match.
</commit_message>
<xml_diff>
--- a/solution_presentation.pptx
+++ b/solution_presentation.pptx
@@ -13332,7 +13332,7 @@
                 <a:ea typeface="Poppins" pitchFamily="34" charset="-122"/>
                 <a:cs typeface="Poppins" pitchFamily="34" charset="-120"/>
               </a:rPr>
-              <a:t>28 contract tests, including one that fails loudly if the optical path degenerates into applyColorMap.</a:t>
+              <a:t>29 contract tests, including one that fails loudly if the optical path degenerates into applyColorMap.</a:t>
             </a:r>
             <a:endParaRPr lang="en-US" sz="1200" dirty="0"/>
           </a:p>
@@ -15278,7 +15278,7 @@
                 <a:ea typeface="Poppins" pitchFamily="34" charset="-122"/>
                 <a:cs typeface="Poppins" pitchFamily="34" charset="-120"/>
               </a:rPr>
-              <a:t>Reproducible: seeded RNG, pinned requirements.txt, 28-test pytest suite, README runs clone → generate → localize → evaluate.</a:t>
+              <a:t>Reproducible: seeded RNG, pinned requirements.txt, 29-test pytest suite, README runs clone → generate → localize → evaluate.</a:t>
             </a:r>
             <a:endParaRPr lang="en-US" sz="1300" dirty="0"/>
           </a:p>
@@ -15491,7 +15491,7 @@
                 <a:ea typeface="Poppins" pitchFamily="34" charset="-122"/>
                 <a:cs typeface="Poppins" pitchFamily="34" charset="-120"/>
               </a:rPr>
-              <a:t>tests/ — 28 tests</a:t>
+              <a:t>tests/ — 29 tests</a:t>
             </a:r>
             <a:endParaRPr lang="en-US" sz="800" dirty="0"/>
           </a:p>

</xml_diff>

<commit_message>
Re-measure --visual-clarity ablation on the current 120-pair basis
The 71.2% (57/80) figure predated the baseline's expansion from 20 to
30 pairs/seed and was flagged in the README as not apples-to-apples
with the 93.33% (112/120) headline number. Re-ran the same four seeds
(42, 101, 202, 303) at the current 30 pairs/seed with --visual-clarity:
21/30, 25/30, 27/30, 25/30 -> 98/120 = 81.67%, a real and now directly
comparable 11.66-point accuracy cost for disabling the fingerprint and
micron-landmark cues.

Commits each seed's results.csv (results/vc42/, vc101/, vc202/,
vc303/), updates every mention of the old 71.2%/57/80 figure in
README.md and src/app.py's in-app copy, and updates the deck (both
slides that quoted it, PDF re-exported to match).
</commit_message>
<xml_diff>
--- a/solution_presentation.pptx
+++ b/solution_presentation.pptx
@@ -13125,7 +13125,7 @@
                 <a:ea typeface="Poppins" pitchFamily="34" charset="-122"/>
                 <a:cs typeface="Poppins" pitchFamily="34" charset="-120"/>
               </a:rPr>
-              <a:t>Honest ablation shipped: the --visual-clarity flag makes cleaner images by disabling both cues — it costs 24 points (71.2 %), off by default.</a:t>
+              <a:t>Honest ablation shipped: the --visual-clarity flag makes cleaner images by disabling both cues — it costs 11.7 points (81.67 %), off by default.</a:t>
             </a:r>
             <a:endParaRPr lang="en-US" sz="1050" dirty="0"/>
           </a:p>
@@ -14480,7 +14480,7 @@
                 <a:ea typeface="Poppins" pitchFamily="34" charset="-122"/>
                 <a:cs typeface="Poppins" pitchFamily="34" charset="-120"/>
               </a:rPr>
-              <a:t>Honest limits: failures concentrate on near-uniform FinFET dies; boundary-straddling crops drop to 85 %; the clean-image build to 71.2 %.</a:t>
+              <a:t>Honest limits: failures concentrate on near-uniform FinFET dies; boundary-straddling crops drop to 85 %; the clean-image build to 81.67 %.</a:t>
             </a:r>
             <a:endParaRPr lang="en-US" sz="1000" dirty="0"/>
           </a:p>

</xml_diff>